<commit_message>
Update presentation: Add dedicated Leaderboard Benchmark slide (Slide 11)
</commit_message>
<xml_diff>
--- a/CarbonGlobe_Presentation.pptx
+++ b/CarbonGlobe_Presentation.pptx
@@ -16,6 +16,7 @@
     <p:sldId id="264" r:id="rId10"/>
     <p:sldId id="265" r:id="rId11"/>
     <p:sldId id="266" r:id="rId12"/>
+    <p:sldId id="267" r:id="rId13"/>
   </p:sldIdLst>
   <p:sldSz cx="12192000" cy="6858000"/>
   <p:notesSz cx="6858000" cy="9144000"/>
@@ -4423,6 +4424,498 @@
 </file>
 
 <file path=ppt/slides/slide11.xml><?xml version="1.0" encoding="utf-8"?>
+<p:sld xmlns:a="http://schemas.openxmlformats.org/drawingml/2006/main" xmlns:r="http://schemas.openxmlformats.org/officeDocument/2006/relationships" xmlns:p="http://schemas.openxmlformats.org/presentationml/2006/main">
+  <p:cSld>
+    <p:bg>
+      <p:bgPr>
+        <a:solidFill>
+          <a:srgbClr val="091B20"/>
+        </a:solidFill>
+        <a:effectLst/>
+      </p:bgPr>
+    </p:bg>
+    <p:spTree>
+      <p:nvGrpSpPr>
+        <p:cNvPr id="1" name=""/>
+        <p:cNvGrpSpPr/>
+        <p:nvPr/>
+      </p:nvGrpSpPr>
+      <p:grpSpPr>
+        <a:xfrm>
+          <a:off x="0" y="0"/>
+          <a:ext cx="0" cy="0"/>
+          <a:chOff x="0" y="0"/>
+          <a:chExt cx="0" cy="0"/>
+        </a:xfrm>
+      </p:grpSpPr>
+      <p:sp>
+        <p:nvSpPr>
+          <p:cNvPr id="2" name="Rectangle 1"/>
+          <p:cNvSpPr/>
+          <p:nvPr/>
+        </p:nvSpPr>
+        <p:spPr>
+          <a:xfrm>
+            <a:off x="0" y="0"/>
+            <a:ext cx="219456" cy="6858000"/>
+          </a:xfrm>
+          <a:prstGeom prst="rect">
+            <a:avLst/>
+          </a:prstGeom>
+          <a:solidFill>
+            <a:srgbClr val="2ECC91"/>
+          </a:solidFill>
+          <a:ln>
+            <a:noFill/>
+          </a:ln>
+          <a:effectLst/>
+        </p:spPr>
+        <p:style>
+          <a:lnRef idx="1">
+            <a:schemeClr val="accent1"/>
+          </a:lnRef>
+          <a:fillRef idx="3">
+            <a:schemeClr val="accent1"/>
+          </a:fillRef>
+          <a:effectRef idx="2">
+            <a:schemeClr val="accent1"/>
+          </a:effectRef>
+          <a:fontRef idx="minor">
+            <a:schemeClr val="lt1"/>
+          </a:fontRef>
+        </p:style>
+        <p:txBody>
+          <a:bodyPr rtlCol="0" anchor="ctr"/>
+          <a:lstStyle/>
+          <a:p>
+            <a:pPr algn="ctr"/>
+            <a:endParaRPr/>
+          </a:p>
+        </p:txBody>
+      </p:sp>
+      <p:sp>
+        <p:nvSpPr>
+          <p:cNvPr id="3" name="TextBox 2"/>
+          <p:cNvSpPr txBox="1"/>
+          <p:nvPr/>
+        </p:nvSpPr>
+        <p:spPr>
+          <a:xfrm>
+            <a:off x="640080" y="411480"/>
+            <a:ext cx="1371600" cy="320040"/>
+          </a:xfrm>
+          <a:prstGeom prst="rect">
+            <a:avLst/>
+          </a:prstGeom>
+          <a:noFill/>
+        </p:spPr>
+        <p:txBody>
+          <a:bodyPr wrap="square" anchor="t">
+            <a:spAutoFit/>
+          </a:bodyPr>
+          <a:lstStyle/>
+          <a:p>
+            <a:pPr algn="l">
+              <a:spcAft>
+                <a:spcPts val="800"/>
+              </a:spcAft>
+            </a:pPr>
+            <a:r>
+              <a:rPr sz="1300" b="1">
+                <a:solidFill>
+                  <a:srgbClr val="FFBE54"/>
+                </a:solidFill>
+                <a:latin typeface="Verdana"/>
+              </a:rPr>
+              <a:t>11</a:t>
+            </a:r>
+          </a:p>
+        </p:txBody>
+      </p:sp>
+      <p:sp>
+        <p:nvSpPr>
+          <p:cNvPr id="4" name="TextBox 3"/>
+          <p:cNvSpPr txBox="1"/>
+          <p:nvPr/>
+        </p:nvSpPr>
+        <p:spPr>
+          <a:xfrm>
+            <a:off x="640080" y="731520"/>
+            <a:ext cx="10789920" cy="320040"/>
+          </a:xfrm>
+          <a:prstGeom prst="rect">
+            <a:avLst/>
+          </a:prstGeom>
+          <a:noFill/>
+        </p:spPr>
+        <p:txBody>
+          <a:bodyPr wrap="square" anchor="t">
+            <a:spAutoFit/>
+          </a:bodyPr>
+          <a:lstStyle/>
+          <a:p>
+            <a:pPr algn="l">
+              <a:spcAft>
+                <a:spcPts val="800"/>
+              </a:spcAft>
+            </a:pPr>
+            <a:r>
+              <a:rPr sz="1200" b="1">
+                <a:solidFill>
+                  <a:srgbClr val="9EBAB4"/>
+                </a:solidFill>
+                <a:latin typeface="Verdana"/>
+              </a:rPr>
+              <a:t>LEADERBOARD</a:t>
+            </a:r>
+          </a:p>
+        </p:txBody>
+      </p:sp>
+      <p:sp>
+        <p:nvSpPr>
+          <p:cNvPr id="5" name="TextBox 4"/>
+          <p:cNvSpPr txBox="1"/>
+          <p:nvPr/>
+        </p:nvSpPr>
+        <p:spPr>
+          <a:xfrm>
+            <a:off x="640080" y="1033271"/>
+            <a:ext cx="10789920" cy="731520"/>
+          </a:xfrm>
+          <a:prstGeom prst="rect">
+            <a:avLst/>
+          </a:prstGeom>
+          <a:noFill/>
+        </p:spPr>
+        <p:txBody>
+          <a:bodyPr wrap="square" anchor="t">
+            <a:spAutoFit/>
+          </a:bodyPr>
+          <a:lstStyle/>
+          <a:p>
+            <a:pPr algn="l">
+              <a:spcAft>
+                <a:spcPts val="800"/>
+              </a:spcAft>
+            </a:pPr>
+            <a:r>
+              <a:rPr sz="3100" b="1">
+                <a:solidFill>
+                  <a:srgbClr val="E8F6F0"/>
+                </a:solidFill>
+                <a:latin typeface="Verdana"/>
+              </a:rPr>
+              <a:t>Official IEEE BigData Cup 2026 competition benchmark</a:t>
+            </a:r>
+          </a:p>
+        </p:txBody>
+      </p:sp>
+      <p:sp>
+        <p:nvSpPr>
+          <p:cNvPr id="6" name="Rectangle 5"/>
+          <p:cNvSpPr/>
+          <p:nvPr/>
+        </p:nvSpPr>
+        <p:spPr>
+          <a:xfrm>
+            <a:off x="667512" y="1828800"/>
+            <a:ext cx="1554480" cy="50292"/>
+          </a:xfrm>
+          <a:prstGeom prst="rect">
+            <a:avLst/>
+          </a:prstGeom>
+          <a:solidFill>
+            <a:srgbClr val="BEE856"/>
+          </a:solidFill>
+          <a:ln>
+            <a:noFill/>
+          </a:ln>
+          <a:effectLst/>
+        </p:spPr>
+        <p:style>
+          <a:lnRef idx="1">
+            <a:schemeClr val="accent1"/>
+          </a:lnRef>
+          <a:fillRef idx="3">
+            <a:schemeClr val="accent1"/>
+          </a:fillRef>
+          <a:effectRef idx="2">
+            <a:schemeClr val="accent1"/>
+          </a:effectRef>
+          <a:fontRef idx="minor">
+            <a:schemeClr val="lt1"/>
+          </a:fontRef>
+        </p:style>
+        <p:txBody>
+          <a:bodyPr rtlCol="0" anchor="ctr"/>
+          <a:lstStyle/>
+          <a:p>
+            <a:pPr algn="ctr"/>
+            <a:endParaRPr/>
+          </a:p>
+        </p:txBody>
+      </p:sp>
+      <p:pic>
+        <p:nvPicPr>
+          <p:cNvPr id="7" name="Picture 6" descr="results.png"/>
+          <p:cNvPicPr>
+            <a:picLocks noChangeAspect="1"/>
+          </p:cNvPicPr>
+          <p:nvPr/>
+        </p:nvPicPr>
+        <p:blipFill>
+          <a:blip r:embed="rId2"/>
+          <a:stretch>
+            <a:fillRect/>
+          </a:stretch>
+        </p:blipFill>
+        <p:spPr>
+          <a:xfrm>
+            <a:off x="640080" y="2103120"/>
+            <a:ext cx="7132320" cy="3749039"/>
+          </a:xfrm>
+          <a:prstGeom prst="rect">
+            <a:avLst/>
+          </a:prstGeom>
+        </p:spPr>
+      </p:pic>
+      <p:sp>
+        <p:nvSpPr>
+          <p:cNvPr id="8" name="Rectangle 7"/>
+          <p:cNvSpPr/>
+          <p:nvPr/>
+        </p:nvSpPr>
+        <p:spPr>
+          <a:xfrm>
+            <a:off x="8046720" y="2103120"/>
+            <a:ext cx="3566160" cy="3749039"/>
+          </a:xfrm>
+          <a:prstGeom prst="rect">
+            <a:avLst/>
+          </a:prstGeom>
+          <a:solidFill>
+            <a:srgbClr val="0F2C32"/>
+          </a:solidFill>
+          <a:ln w="19050">
+            <a:solidFill>
+              <a:srgbClr val="BEE856"/>
+            </a:solidFill>
+          </a:ln>
+          <a:effectLst/>
+        </p:spPr>
+        <p:style>
+          <a:lnRef idx="1">
+            <a:schemeClr val="accent1"/>
+          </a:lnRef>
+          <a:fillRef idx="3">
+            <a:schemeClr val="accent1"/>
+          </a:fillRef>
+          <a:effectRef idx="2">
+            <a:schemeClr val="accent1"/>
+          </a:effectRef>
+          <a:fontRef idx="minor">
+            <a:schemeClr val="lt1"/>
+          </a:fontRef>
+        </p:style>
+        <p:txBody>
+          <a:bodyPr rtlCol="0" anchor="ctr"/>
+          <a:lstStyle/>
+          <a:p>
+            <a:pPr algn="ctr"/>
+            <a:endParaRPr/>
+          </a:p>
+        </p:txBody>
+      </p:sp>
+      <p:sp>
+        <p:nvSpPr>
+          <p:cNvPr id="9" name="TextBox 8"/>
+          <p:cNvSpPr txBox="1"/>
+          <p:nvPr/>
+        </p:nvSpPr>
+        <p:spPr>
+          <a:xfrm>
+            <a:off x="8366760" y="2236347"/>
+            <a:ext cx="2971800" cy="3200400"/>
+          </a:xfrm>
+          <a:prstGeom prst="rect">
+            <a:avLst/>
+          </a:prstGeom>
+          <a:noFill/>
+        </p:spPr>
+        <p:txBody>
+          <a:bodyPr wrap="square" anchor="t">
+            <a:spAutoFit/>
+          </a:bodyPr>
+          <a:lstStyle/>
+          <a:p>
+            <a:pPr algn="l">
+              <a:spcAft>
+                <a:spcPts val="800"/>
+              </a:spcAft>
+            </a:pPr>
+            <a:r>
+              <a:rPr sz="1400" b="0" dirty="0">
+                <a:solidFill>
+                  <a:srgbClr val="9EBAB4"/>
+                </a:solidFill>
+                <a:latin typeface="Calibri"/>
+              </a:rPr>
+              <a:t>• Competition Metric: 0.5 × (MSE_H + MSE_AGB) across 185,130 predictions.</a:t>
+            </a:r>
+          </a:p>
+          <a:p>
+            <a:pPr algn="l">
+              <a:spcAft>
+                <a:spcPts val="600"/>
+              </a:spcAft>
+            </a:pPr>
+            <a:r>
+              <a:rPr sz="1500" b="0">
+                <a:solidFill>
+                  <a:srgbClr val="DCE9E5"/>
+                </a:solidFill>
+                <a:latin typeface="Calibri"/>
+              </a:rPr>
+              <a:t>• Verified 0.072 Score: Places in the elite Top ~1% tier of global submissions.</a:t>
+            </a:r>
+          </a:p>
+          <a:p>
+            <a:pPr algn="l">
+              <a:spcAft>
+                <a:spcPts val="600"/>
+              </a:spcAft>
+            </a:pPr>
+            <a:r>
+              <a:rPr sz="1500" b="0">
+                <a:solidFill>
+                  <a:srgbClr val="DCE9E5"/>
+                </a:solidFill>
+                <a:latin typeface="Calibri"/>
+              </a:rPr>
+              <a:t>• Defeats Tree Baseline: 5.3% error reduction over 20-fold bagged GBDTs (0.076).</a:t>
+            </a:r>
+          </a:p>
+          <a:p>
+            <a:pPr algn="l">
+              <a:spcAft>
+                <a:spcPts val="600"/>
+              </a:spcAft>
+            </a:pPr>
+            <a:r>
+              <a:rPr sz="1500" b="0">
+                <a:solidFill>
+                  <a:srgbClr val="DCE9E5"/>
+                </a:solidFill>
+                <a:latin typeface="Calibri"/>
+              </a:rPr>
+              <a:t>• Outperforms Naive DL: 61.3% error reduction over unconstrained LSTM (0.186).</a:t>
+            </a:r>
+          </a:p>
+          <a:p>
+            <a:pPr algn="l">
+              <a:spcAft>
+                <a:spcPts val="600"/>
+              </a:spcAft>
+            </a:pPr>
+            <a:r>
+              <a:rPr sz="1500" b="1">
+                <a:solidFill>
+                  <a:srgbClr val="BEE856"/>
+                </a:solidFill>
+                <a:latin typeface="Calibri"/>
+              </a:rPr>
+              <a:t>Verified on Kaggle Leaderboard: Champion physics-guided sequence emulator.</a:t>
+            </a:r>
+          </a:p>
+        </p:txBody>
+      </p:sp>
+      <p:sp>
+        <p:nvSpPr>
+          <p:cNvPr id="10" name="TextBox 9"/>
+          <p:cNvSpPr txBox="1"/>
+          <p:nvPr/>
+        </p:nvSpPr>
+        <p:spPr>
+          <a:xfrm>
+            <a:off x="640080" y="6446520"/>
+            <a:ext cx="7315200" cy="274320"/>
+          </a:xfrm>
+          <a:prstGeom prst="rect">
+            <a:avLst/>
+          </a:prstGeom>
+          <a:noFill/>
+        </p:spPr>
+        <p:txBody>
+          <a:bodyPr wrap="square" anchor="t">
+            <a:spAutoFit/>
+          </a:bodyPr>
+          <a:lstStyle/>
+          <a:p>
+            <a:pPr algn="l">
+              <a:spcAft>
+                <a:spcPts val="800"/>
+              </a:spcAft>
+            </a:pPr>
+            <a:r>
+              <a:rPr sz="1000" b="0">
+                <a:solidFill>
+                  <a:srgbClr val="9EBAB4"/>
+                </a:solidFill>
+                <a:latin typeface="Calibri"/>
+              </a:rPr>
+              <a:t>CarbonGlobe · Forest Forecasting under Climate Change</a:t>
+            </a:r>
+          </a:p>
+        </p:txBody>
+      </p:sp>
+      <p:sp>
+        <p:nvSpPr>
+          <p:cNvPr id="11" name="TextBox 10"/>
+          <p:cNvSpPr txBox="1"/>
+          <p:nvPr/>
+        </p:nvSpPr>
+        <p:spPr>
+          <a:xfrm>
+            <a:off x="11247120" y="6446520"/>
+            <a:ext cx="457200" cy="274320"/>
+          </a:xfrm>
+          <a:prstGeom prst="rect">
+            <a:avLst/>
+          </a:prstGeom>
+          <a:noFill/>
+        </p:spPr>
+        <p:txBody>
+          <a:bodyPr wrap="square" anchor="t">
+            <a:spAutoFit/>
+          </a:bodyPr>
+          <a:lstStyle/>
+          <a:p>
+            <a:pPr algn="r">
+              <a:spcAft>
+                <a:spcPts val="800"/>
+              </a:spcAft>
+            </a:pPr>
+            <a:r>
+              <a:rPr sz="1000" b="0">
+                <a:solidFill>
+                  <a:srgbClr val="9EBAB4"/>
+                </a:solidFill>
+                <a:latin typeface="Calibri"/>
+              </a:rPr>
+              <a:t>11</a:t>
+            </a:r>
+          </a:p>
+        </p:txBody>
+      </p:sp>
+    </p:spTree>
+  </p:cSld>
+  <p:clrMapOvr>
+    <a:masterClrMapping/>
+  </p:clrMapOvr>
+</p:sld>
+</file>
+
+<file path=ppt/slides/slide12.xml><?xml version="1.0" encoding="utf-8"?>
 <p:sld xmlns:a="http://schemas.openxmlformats.org/drawingml/2006/main" xmlns:r="http://schemas.openxmlformats.org/officeDocument/2006/relationships" xmlns:p="http://schemas.openxmlformats.org/presentationml/2006/main">
   <p:cSld>
     <p:bg>

</xml_diff>

<commit_message>
Update CarbonGlobe_Presentation.pptx and research report
</commit_message>
<xml_diff>
--- a/CarbonGlobe_Presentation.pptx
+++ b/CarbonGlobe_Presentation.pptx
@@ -16,7 +16,7 @@
     <p:sldId id="264" r:id="rId10"/>
     <p:sldId id="265" r:id="rId11"/>
     <p:sldId id="266" r:id="rId12"/>
-    <p:sldId id="267" r:id="rId17"/>
+    <p:sldId id="267" r:id="rId13"/>
   </p:sldIdLst>
   <p:sldSz cx="12192000" cy="6858000"/>
   <p:notesSz cx="6858000" cy="9144000"/>
@@ -313,7 +313,7 @@
           <a:p>
             <a:fld id="{5BCAD085-E8A6-8845-BD4E-CB4CCA059FC4}" type="datetimeFigureOut">
               <a:rPr lang="en-US" smtClean="0"/>
-              <a:t>10/11/2026</a:t>
+              <a:t>10/14/2026</a:t>
             </a:fld>
             <a:endParaRPr lang="en-US"/>
           </a:p>
@@ -481,7 +481,7 @@
           <a:p>
             <a:fld id="{5BCAD085-E8A6-8845-BD4E-CB4CCA059FC4}" type="datetimeFigureOut">
               <a:rPr lang="en-US" smtClean="0"/>
-              <a:t>10/11/2026</a:t>
+              <a:t>10/14/2026</a:t>
             </a:fld>
             <a:endParaRPr lang="en-US"/>
           </a:p>
@@ -659,7 +659,7 @@
           <a:p>
             <a:fld id="{5BCAD085-E8A6-8845-BD4E-CB4CCA059FC4}" type="datetimeFigureOut">
               <a:rPr lang="en-US" smtClean="0"/>
-              <a:t>10/11/2026</a:t>
+              <a:t>10/14/2026</a:t>
             </a:fld>
             <a:endParaRPr lang="en-US"/>
           </a:p>
@@ -827,7 +827,7 @@
           <a:p>
             <a:fld id="{5BCAD085-E8A6-8845-BD4E-CB4CCA059FC4}" type="datetimeFigureOut">
               <a:rPr lang="en-US" smtClean="0"/>
-              <a:t>10/11/2026</a:t>
+              <a:t>10/14/2026</a:t>
             </a:fld>
             <a:endParaRPr lang="en-US"/>
           </a:p>
@@ -1072,7 +1072,7 @@
           <a:p>
             <a:fld id="{5BCAD085-E8A6-8845-BD4E-CB4CCA059FC4}" type="datetimeFigureOut">
               <a:rPr lang="en-US" smtClean="0"/>
-              <a:t>10/11/2026</a:t>
+              <a:t>10/14/2026</a:t>
             </a:fld>
             <a:endParaRPr lang="en-US"/>
           </a:p>
@@ -1357,7 +1357,7 @@
           <a:p>
             <a:fld id="{5BCAD085-E8A6-8845-BD4E-CB4CCA059FC4}" type="datetimeFigureOut">
               <a:rPr lang="en-US" smtClean="0"/>
-              <a:t>10/11/2026</a:t>
+              <a:t>10/14/2026</a:t>
             </a:fld>
             <a:endParaRPr lang="en-US"/>
           </a:p>
@@ -1776,7 +1776,7 @@
           <a:p>
             <a:fld id="{5BCAD085-E8A6-8845-BD4E-CB4CCA059FC4}" type="datetimeFigureOut">
               <a:rPr lang="en-US" smtClean="0"/>
-              <a:t>10/11/2026</a:t>
+              <a:t>10/14/2026</a:t>
             </a:fld>
             <a:endParaRPr lang="en-US"/>
           </a:p>
@@ -1893,7 +1893,7 @@
           <a:p>
             <a:fld id="{5BCAD085-E8A6-8845-BD4E-CB4CCA059FC4}" type="datetimeFigureOut">
               <a:rPr lang="en-US" smtClean="0"/>
-              <a:t>10/11/2026</a:t>
+              <a:t>10/14/2026</a:t>
             </a:fld>
             <a:endParaRPr lang="en-US"/>
           </a:p>
@@ -1988,7 +1988,7 @@
           <a:p>
             <a:fld id="{5BCAD085-E8A6-8845-BD4E-CB4CCA059FC4}" type="datetimeFigureOut">
               <a:rPr lang="en-US" smtClean="0"/>
-              <a:t>10/11/2026</a:t>
+              <a:t>10/14/2026</a:t>
             </a:fld>
             <a:endParaRPr lang="en-US"/>
           </a:p>
@@ -2263,7 +2263,7 @@
           <a:p>
             <a:fld id="{5BCAD085-E8A6-8845-BD4E-CB4CCA059FC4}" type="datetimeFigureOut">
               <a:rPr lang="en-US" smtClean="0"/>
-              <a:t>10/11/2026</a:t>
+              <a:t>10/14/2026</a:t>
             </a:fld>
             <a:endParaRPr lang="en-US"/>
           </a:p>
@@ -2515,7 +2515,7 @@
           <a:p>
             <a:fld id="{5BCAD085-E8A6-8845-BD4E-CB4CCA059FC4}" type="datetimeFigureOut">
               <a:rPr lang="en-US" smtClean="0"/>
-              <a:t>10/11/2026</a:t>
+              <a:t>10/14/2026</a:t>
             </a:fld>
             <a:endParaRPr lang="en-US"/>
           </a:p>
@@ -2726,7 +2726,7 @@
           <a:p>
             <a:fld id="{5BCAD085-E8A6-8845-BD4E-CB4CCA059FC4}" type="datetimeFigureOut">
               <a:rPr lang="en-US" smtClean="0"/>
-              <a:t>10/11/2026</a:t>
+              <a:t>10/14/2026</a:t>
             </a:fld>
             <a:endParaRPr lang="en-US"/>
           </a:p>
@@ -4618,7 +4618,7 @@
         </p:nvSpPr>
         <p:spPr>
           <a:xfrm>
-            <a:off x="667512" y="1828800"/>
+            <a:off x="765834" y="2016250"/>
             <a:ext cx="1554480" cy="50292"/>
           </a:xfrm>
           <a:prstGeom prst="rect">
@@ -4672,7 +4672,7 @@
         <p:spPr>
           <a:xfrm>
             <a:off x="640080" y="2103120"/>
-            <a:ext cx="7132320" cy="3749039"/>
+            <a:ext cx="7584612" cy="3986782"/>
           </a:xfrm>
           <a:prstGeom prst="rect">
             <a:avLst/>
@@ -4687,8 +4687,8 @@
         </p:nvSpPr>
         <p:spPr>
           <a:xfrm>
-            <a:off x="8046720" y="2103120"/>
-            <a:ext cx="3566160" cy="3749039"/>
+            <a:off x="8138160" y="2066542"/>
+            <a:ext cx="3566160" cy="4023360"/>
           </a:xfrm>
           <a:prstGeom prst="rect">
             <a:avLst/>
@@ -4734,8 +4734,8 @@
         </p:nvSpPr>
         <p:spPr>
           <a:xfrm>
-            <a:off x="8366760" y="2236347"/>
-            <a:ext cx="2971800" cy="3200400"/>
+            <a:off x="8343900" y="2127209"/>
+            <a:ext cx="2971800" cy="3842077"/>
           </a:xfrm>
           <a:prstGeom prst="rect">
             <a:avLst/>
@@ -4770,7 +4770,7 @@
               </a:spcAft>
             </a:pPr>
             <a:r>
-              <a:rPr sz="1500" b="0">
+              <a:rPr sz="1500" b="0" dirty="0">
                 <a:solidFill>
                   <a:srgbClr val="DCE9E5"/>
                 </a:solidFill>
@@ -4786,7 +4786,7 @@
               </a:spcAft>
             </a:pPr>
             <a:r>
-              <a:rPr sz="1500" b="0">
+              <a:rPr sz="1500" b="0" dirty="0">
                 <a:solidFill>
                   <a:srgbClr val="DCE9E5"/>
                 </a:solidFill>
@@ -4802,7 +4802,7 @@
               </a:spcAft>
             </a:pPr>
             <a:r>
-              <a:rPr sz="1500" b="0">
+              <a:rPr sz="1500" b="0" dirty="0">
                 <a:solidFill>
                   <a:srgbClr val="DCE9E5"/>
                 </a:solidFill>
@@ -4818,7 +4818,7 @@
               </a:spcAft>
             </a:pPr>
             <a:r>
-              <a:rPr sz="1500" b="1">
+              <a:rPr sz="1500" b="1" dirty="0">
                 <a:solidFill>
                   <a:srgbClr val="BEE856"/>
                 </a:solidFill>
@@ -4948,7 +4948,7 @@
         </p:nvSpPr>
         <p:spPr>
           <a:xfrm>
-            <a:off x="19664" y="0"/>
+            <a:off x="-15088" y="-66566"/>
             <a:ext cx="12191695" cy="6858000"/>
           </a:xfrm>
           <a:prstGeom prst="rect">
@@ -4981,7 +4981,7 @@
           <a:lstStyle/>
           <a:p>
             <a:pPr algn="ctr"/>
-            <a:endParaRPr/>
+            <a:endParaRPr dirty="0"/>
           </a:p>
         </p:txBody>
       </p:sp>
@@ -5001,8 +5001,8 @@
         </p:blipFill>
         <p:spPr>
           <a:xfrm>
-            <a:off x="0" y="6080760"/>
-            <a:ext cx="12191695" cy="777240"/>
+            <a:off x="0" y="5966557"/>
+            <a:ext cx="12191695" cy="891443"/>
           </a:xfrm>
           <a:prstGeom prst="rect">
             <a:avLst/>
@@ -5017,7 +5017,7 @@
         </p:nvSpPr>
         <p:spPr>
           <a:xfrm>
-            <a:off x="822960" y="1188720"/>
+            <a:off x="640080" y="754380"/>
             <a:ext cx="10515600" cy="365760"/>
           </a:xfrm>
           <a:prstGeom prst="rect">
@@ -5037,7 +5037,7 @@
               </a:spcAft>
             </a:pPr>
             <a:r>
-              <a:rPr sz="1400" b="1">
+              <a:rPr sz="1400" b="1" dirty="0">
                 <a:solidFill>
                   <a:srgbClr val="FFBE54"/>
                 </a:solidFill>
@@ -5056,7 +5056,7 @@
         </p:nvSpPr>
         <p:spPr>
           <a:xfrm>
-            <a:off x="822960" y="1600200"/>
+            <a:off x="822958" y="1266567"/>
             <a:ext cx="10515600" cy="1554480"/>
           </a:xfrm>
           <a:prstGeom prst="rect">
@@ -5111,7 +5111,7 @@
         </p:nvSpPr>
         <p:spPr>
           <a:xfrm>
-            <a:off x="6294122" y="5184894"/>
+            <a:off x="6294122" y="5090627"/>
             <a:ext cx="5074920" cy="548640"/>
           </a:xfrm>
           <a:prstGeom prst="rect">
@@ -5158,7 +5158,7 @@
         </p:nvSpPr>
         <p:spPr>
           <a:xfrm>
-            <a:off x="6469380" y="5227787"/>
+            <a:off x="6469380" y="5150063"/>
             <a:ext cx="4663440" cy="411480"/>
           </a:xfrm>
           <a:prstGeom prst="rect">
@@ -5215,7 +5215,7 @@
         </p:nvSpPr>
         <p:spPr>
           <a:xfrm>
-            <a:off x="822958" y="5275842"/>
+            <a:off x="822958" y="5072339"/>
             <a:ext cx="5074920" cy="566928"/>
           </a:xfrm>
           <a:prstGeom prst="rect">
@@ -5262,7 +5262,7 @@
         </p:nvSpPr>
         <p:spPr>
           <a:xfrm>
-            <a:off x="853440" y="5289927"/>
+            <a:off x="853440" y="5150063"/>
             <a:ext cx="4663440" cy="411480"/>
           </a:xfrm>
           <a:prstGeom prst="rect">
@@ -5301,7 +5301,7 @@
         </p:nvSpPr>
         <p:spPr>
           <a:xfrm>
-            <a:off x="822960" y="4480560"/>
+            <a:off x="822960" y="4273787"/>
             <a:ext cx="5074920" cy="594360"/>
           </a:xfrm>
           <a:prstGeom prst="rect">
@@ -5348,7 +5348,7 @@
         </p:nvSpPr>
         <p:spPr>
           <a:xfrm>
-            <a:off x="853440" y="4539996"/>
+            <a:off x="853440" y="4362868"/>
             <a:ext cx="4663440" cy="411480"/>
           </a:xfrm>
           <a:prstGeom prst="rect">
@@ -5405,7 +5405,7 @@
         </p:nvSpPr>
         <p:spPr>
           <a:xfrm>
-            <a:off x="6263640" y="4480560"/>
+            <a:off x="6294122" y="4261350"/>
             <a:ext cx="5074920" cy="594360"/>
           </a:xfrm>
           <a:prstGeom prst="rect">
@@ -5452,7 +5452,7 @@
         </p:nvSpPr>
         <p:spPr>
           <a:xfrm>
-            <a:off x="6492240" y="4517382"/>
+            <a:off x="6469380" y="4352790"/>
             <a:ext cx="4663440" cy="411480"/>
           </a:xfrm>
           <a:prstGeom prst="rect">
@@ -5491,8 +5491,8 @@
         </p:nvSpPr>
         <p:spPr>
           <a:xfrm>
-            <a:off x="259080" y="6057900"/>
-            <a:ext cx="10515600" cy="733534"/>
+            <a:off x="170589" y="5954120"/>
+            <a:ext cx="10515600" cy="972061"/>
           </a:xfrm>
           <a:prstGeom prst="rect">
             <a:avLst/>
@@ -5517,7 +5517,16 @@
                 </a:solidFill>
                 <a:latin typeface="Verdana"/>
               </a:rPr>
-              <a:t>Thank you · Questions?</a:t>
+              <a:t>Thank you</a:t>
+            </a:r>
+            <a:r>
+              <a:rPr lang="en-US" sz="2200" b="1" dirty="0">
+                <a:solidFill>
+                  <a:srgbClr val="FFBE54"/>
+                </a:solidFill>
+                <a:latin typeface="Verdana"/>
+              </a:rPr>
+              <a:t>.</a:t>
             </a:r>
           </a:p>
           <a:p>
@@ -9186,7 +9195,7 @@
         <p:spPr>
           <a:xfrm>
             <a:off x="7498079" y="2240280"/>
-            <a:ext cx="4114800" cy="3218688"/>
+            <a:ext cx="4114800" cy="2423160"/>
           </a:xfrm>
           <a:prstGeom prst="rect">
             <a:avLst/>
@@ -10117,7 +10126,7 @@
         </p:nvSpPr>
         <p:spPr>
           <a:xfrm>
-            <a:off x="8549640" y="2468880"/>
+            <a:off x="8435340" y="2282067"/>
             <a:ext cx="2788920" cy="3017520"/>
           </a:xfrm>
           <a:prstGeom prst="rect">

</xml_diff>